<commit_message>
chore: commit recent research deliverables
</commit_message>
<xml_diff>
--- a/presentations/task-020-group-topic-excerpt/Harness_课题介绍_原理与案例_模板版.pptx
+++ b/presentations/task-020-group-topic-excerpt/Harness_课题介绍_原理与案例_模板版.pptx
@@ -9,11 +9,11 @@
     <p:notesMasterId r:id="rId5"/>
   </p:notesMasterIdLst>
   <p:handoutMasterIdLst>
-    <p:handoutMasterId r:id="rId19"/>
+    <p:handoutMasterId r:id="rId7"/>
   </p:handoutMasterIdLst>
   <p:sldIdLst>
-    <p:sldId id="2273" r:id="rId8"/>
-    <p:sldId id="2296" r:id="rId10"/>
+    <p:sldId id="2273" r:id="rId4"/>
+    <p:sldId id="2296" r:id="rId6"/>
   </p:sldIdLst>
   <p:sldSz cx="12192000" cy="6858000"/>
   <p:notesSz cx="6784975" cy="9918700"/>
@@ -654,7 +654,7 @@
 </p:notesMaster>
 </file>
 
-<file path=ppt/notesSlides/notesSlide4.xml><?xml version="1.0" encoding="utf-8"?>
+<file path=ppt/notesSlides/notesSlide1.xml><?xml version="1.0" encoding="utf-8"?>
 <p:notes xmlns:a="http://schemas.openxmlformats.org/drawingml/2006/main" xmlns:r="http://schemas.openxmlformats.org/officeDocument/2006/relationships" xmlns:p="http://schemas.openxmlformats.org/presentationml/2006/main">
   <p:cSld>
     <p:spTree>
@@ -734,7 +734,7 @@
 </p:notes>
 </file>
 
-<file path=ppt/notesSlides/notesSlide6.xml><?xml version="1.0" encoding="utf-8"?>
+<file path=ppt/notesSlides/notesSlide2.xml><?xml version="1.0" encoding="utf-8"?>
 <p:notes xmlns:a="http://schemas.openxmlformats.org/drawingml/2006/main" xmlns:r="http://schemas.openxmlformats.org/officeDocument/2006/relationships" xmlns:p="http://schemas.openxmlformats.org/presentationml/2006/main">
   <p:cSld>
     <p:spTree>
@@ -1113,7 +1113,7 @@
           </a:fontRef>
         </p:style>
         <p:txBody>
-          <a:bodyPr lIns="73152" rIns="73152" rtlCol="0" anchor="ctr" tIns="27432" bIns="27432" wrap="square"/>
+          <a:bodyPr wrap="square" lIns="73152" tIns="27432" rIns="73152" bIns="27432" rtlCol="0" anchor="ctr"/>
           <a:lstStyle/>
           <a:p>
             <a:pPr algn="ctr">
@@ -1128,12 +1128,12 @@
               </a:spcAft>
             </a:pPr>
             <a:r>
-              <a:rPr sz="2200" b="0" lang="zh-CN">
+              <a:rPr lang="zh-CN" sz="2200" b="0">
                 <a:solidFill>
                   <a:srgbClr val="5A5A5A"/>
                 </a:solidFill>
-                <a:latin typeface="微软雅黑"/>
-                <a:ea typeface="微软雅黑"/>
+                <a:latin typeface="微软雅黑" panose="020B0503020204020204" charset="-122"/>
+                <a:ea typeface="微软雅黑" panose="020B0503020204020204" charset="-122"/>
               </a:rPr>
               <a:t>课题方向</a:t>
             </a:r>
@@ -1144,8 +1144,8 @@
                   <a:lumOff val="25000"/>
                 </a:schemeClr>
               </a:solidFill>
-              <a:latin typeface="微软雅黑" panose="020B0503020204020204" pitchFamily="34" charset="-122"/>
-              <a:ea typeface="微软雅黑" panose="020B0503020204020204" pitchFamily="34" charset="-122"/>
+              <a:latin typeface="微软雅黑" panose="020B0503020204020204" charset="-122"/>
+              <a:ea typeface="微软雅黑" panose="020B0503020204020204" charset="-122"/>
               <a:cs typeface="Calibri" panose="020F0502020204030204" pitchFamily="34" charset="0"/>
             </a:endParaRPr>
           </a:p>
@@ -1196,7 +1196,7 @@
           </a:fontRef>
         </p:style>
         <p:txBody>
-          <a:bodyPr lIns="73152" rIns="73152" rtlCol="0" anchor="ctr" tIns="27432" bIns="27432" wrap="square"/>
+          <a:bodyPr wrap="square" lIns="73152" tIns="27432" rIns="73152" bIns="27432" rtlCol="0" anchor="ctr"/>
           <a:lstStyle/>
           <a:p>
             <a:pPr algn="ctr">
@@ -1211,12 +1211,12 @@
               </a:spcAft>
             </a:pPr>
             <a:r>
-              <a:rPr sz="2200" b="0" lang="zh-CN">
+              <a:rPr lang="zh-CN" sz="2200" b="0">
                 <a:solidFill>
                   <a:srgbClr val="5A5A5A"/>
                 </a:solidFill>
-                <a:latin typeface="微软雅黑"/>
-                <a:ea typeface="微软雅黑"/>
+                <a:latin typeface="微软雅黑" panose="020B0503020204020204" charset="-122"/>
+                <a:ea typeface="微软雅黑" panose="020B0503020204020204" charset="-122"/>
               </a:rPr>
               <a:t>技术原理</a:t>
             </a:r>
@@ -1227,8 +1227,8 @@
                   <a:lumOff val="25000"/>
                 </a:schemeClr>
               </a:solidFill>
-              <a:latin typeface="微软雅黑" panose="020B0503020204020204" pitchFamily="34" charset="-122"/>
-              <a:ea typeface="微软雅黑" panose="020B0503020204020204" pitchFamily="34" charset="-122"/>
+              <a:latin typeface="微软雅黑" panose="020B0503020204020204" charset="-122"/>
+              <a:ea typeface="微软雅黑" panose="020B0503020204020204" charset="-122"/>
               <a:cs typeface="Calibri" panose="020F0502020204030204" pitchFamily="34" charset="0"/>
             </a:endParaRPr>
           </a:p>
@@ -1279,7 +1279,7 @@
           </a:fontRef>
         </p:style>
         <p:txBody>
-          <a:bodyPr lIns="73152" rIns="73152" rtlCol="0" anchor="ctr" tIns="27432" bIns="27432" wrap="square"/>
+          <a:bodyPr wrap="square" lIns="73152" tIns="27432" rIns="73152" bIns="27432" rtlCol="0" anchor="ctr"/>
           <a:lstStyle/>
           <a:p>
             <a:pPr algn="ctr">
@@ -1294,12 +1294,12 @@
               </a:spcAft>
             </a:pPr>
             <a:r>
-              <a:rPr sz="2200" b="0" lang="zh-CN">
+              <a:rPr lang="zh-CN" sz="2200" b="0">
                 <a:solidFill>
                   <a:srgbClr val="5A5A5A"/>
                 </a:solidFill>
-                <a:latin typeface="微软雅黑"/>
-                <a:ea typeface="微软雅黑"/>
+                <a:latin typeface="微软雅黑" panose="020B0503020204020204" charset="-122"/>
+                <a:ea typeface="微软雅黑" panose="020B0503020204020204" charset="-122"/>
               </a:rPr>
               <a:t>代表案例</a:t>
             </a:r>
@@ -1310,8 +1310,8 @@
                   <a:lumOff val="25000"/>
                 </a:schemeClr>
               </a:solidFill>
-              <a:latin typeface="微软雅黑" panose="020B0503020204020204" pitchFamily="34" charset="-122"/>
-              <a:ea typeface="微软雅黑" panose="020B0503020204020204" pitchFamily="34" charset="-122"/>
+              <a:latin typeface="微软雅黑" panose="020B0503020204020204" charset="-122"/>
+              <a:ea typeface="微软雅黑" panose="020B0503020204020204" charset="-122"/>
               <a:cs typeface="Calibri" panose="020F0502020204030204" pitchFamily="34" charset="0"/>
             </a:endParaRPr>
           </a:p>
@@ -1362,7 +1362,7 @@
           </a:fontRef>
         </p:style>
         <p:txBody>
-          <a:bodyPr lIns="73152" rIns="73152" rtlCol="0" anchor="ctr" tIns="27432" bIns="27432" wrap="square"/>
+          <a:bodyPr wrap="square" lIns="73152" tIns="27432" rIns="73152" bIns="27432" rtlCol="0" anchor="ctr"/>
           <a:lstStyle/>
           <a:p>
             <a:pPr algn="ctr">
@@ -1377,12 +1377,12 @@
               </a:spcAft>
             </a:pPr>
             <a:r>
-              <a:rPr sz="2200" b="0" lang="zh-CN">
+              <a:rPr lang="zh-CN" sz="2200" b="0">
                 <a:solidFill>
                   <a:srgbClr val="5A5A5A"/>
                 </a:solidFill>
-                <a:latin typeface="微软雅黑"/>
-                <a:ea typeface="微软雅黑"/>
+                <a:latin typeface="微软雅黑" panose="020B0503020204020204" charset="-122"/>
+                <a:ea typeface="微软雅黑" panose="020B0503020204020204" charset="-122"/>
               </a:rPr>
               <a:t>研究展望</a:t>
             </a:r>
@@ -1393,8 +1393,8 @@
                   <a:lumOff val="25000"/>
                 </a:schemeClr>
               </a:solidFill>
-              <a:latin typeface="微软雅黑" panose="020B0503020204020204" pitchFamily="34" charset="-122"/>
-              <a:ea typeface="微软雅黑" panose="020B0503020204020204" pitchFamily="34" charset="-122"/>
+              <a:latin typeface="微软雅黑" panose="020B0503020204020204" charset="-122"/>
+              <a:ea typeface="微软雅黑" panose="020B0503020204020204" charset="-122"/>
               <a:cs typeface="Calibri" panose="020F0502020204030204" pitchFamily="34" charset="0"/>
             </a:endParaRPr>
           </a:p>
@@ -1424,8 +1424,8 @@
                 <a:solidFill>
                   <a:schemeClr val="tx1"/>
                 </a:solidFill>
-                <a:latin typeface="微软雅黑" panose="020B0503020204020204" pitchFamily="34" charset="-122"/>
-                <a:ea typeface="微软雅黑" panose="020B0503020204020204" pitchFamily="34" charset="-122"/>
+                <a:latin typeface="微软雅黑" panose="020B0503020204020204" charset="-122"/>
+                <a:ea typeface="微软雅黑" panose="020B0503020204020204" charset="-122"/>
                 <a:cs typeface="Arial" panose="020B0604020202020204" pitchFamily="34" charset="0"/>
               </a:defRPr>
             </a:lvl1pPr>
@@ -3760,7 +3760,7 @@
           </a:fontRef>
         </p:style>
         <p:txBody>
-          <a:bodyPr lIns="73152" rIns="73152" rtlCol="0" anchor="ctr" tIns="27432" bIns="27432" wrap="square"/>
+          <a:bodyPr wrap="square" lIns="73152" tIns="27432" rIns="73152" bIns="27432" rtlCol="0" anchor="ctr"/>
           <a:lstStyle/>
           <a:p>
             <a:pPr algn="ctr">
@@ -3775,12 +3775,12 @@
               </a:spcAft>
             </a:pPr>
             <a:r>
-              <a:rPr sz="2200" b="0" lang="zh-CN">
+              <a:rPr lang="zh-CN" sz="2200" b="0">
                 <a:solidFill>
                   <a:srgbClr val="5A5A5A"/>
                 </a:solidFill>
-                <a:latin typeface="微软雅黑"/>
-                <a:ea typeface="微软雅黑"/>
+                <a:latin typeface="微软雅黑" panose="020B0503020204020204" charset="-122"/>
+                <a:ea typeface="微软雅黑" panose="020B0503020204020204" charset="-122"/>
               </a:rPr>
               <a:t>课题方向</a:t>
             </a:r>
@@ -3791,8 +3791,8 @@
                   <a:lumOff val="25000"/>
                 </a:schemeClr>
               </a:solidFill>
-              <a:latin typeface="微软雅黑" panose="020B0503020204020204" pitchFamily="34" charset="-122"/>
-              <a:ea typeface="微软雅黑" panose="020B0503020204020204" pitchFamily="34" charset="-122"/>
+              <a:latin typeface="微软雅黑" panose="020B0503020204020204" charset="-122"/>
+              <a:ea typeface="微软雅黑" panose="020B0503020204020204" charset="-122"/>
               <a:cs typeface="Calibri" panose="020F0502020204030204" pitchFamily="34" charset="0"/>
             </a:endParaRPr>
           </a:p>
@@ -3843,7 +3843,7 @@
           </a:fontRef>
         </p:style>
         <p:txBody>
-          <a:bodyPr lIns="73152" rIns="73152" rtlCol="0" anchor="ctr" tIns="27432" bIns="27432" wrap="square"/>
+          <a:bodyPr wrap="square" lIns="73152" tIns="27432" rIns="73152" bIns="27432" rtlCol="0" anchor="ctr"/>
           <a:lstStyle/>
           <a:p>
             <a:pPr algn="ctr">
@@ -3858,12 +3858,12 @@
               </a:spcAft>
             </a:pPr>
             <a:r>
-              <a:rPr sz="2200" b="0" lang="zh-CN">
+              <a:rPr lang="zh-CN" sz="2200" b="0">
                 <a:solidFill>
                   <a:srgbClr val="5A5A5A"/>
                 </a:solidFill>
-                <a:latin typeface="微软雅黑"/>
-                <a:ea typeface="微软雅黑"/>
+                <a:latin typeface="微软雅黑" panose="020B0503020204020204" charset="-122"/>
+                <a:ea typeface="微软雅黑" panose="020B0503020204020204" charset="-122"/>
               </a:rPr>
               <a:t>技术原理</a:t>
             </a:r>
@@ -3874,8 +3874,8 @@
                   <a:lumOff val="25000"/>
                 </a:schemeClr>
               </a:solidFill>
-              <a:latin typeface="微软雅黑" panose="020B0503020204020204" pitchFamily="34" charset="-122"/>
-              <a:ea typeface="微软雅黑" panose="020B0503020204020204" pitchFamily="34" charset="-122"/>
+              <a:latin typeface="微软雅黑" panose="020B0503020204020204" charset="-122"/>
+              <a:ea typeface="微软雅黑" panose="020B0503020204020204" charset="-122"/>
               <a:cs typeface="Calibri" panose="020F0502020204030204" pitchFamily="34" charset="0"/>
             </a:endParaRPr>
           </a:p>
@@ -3926,7 +3926,7 @@
           </a:fontRef>
         </p:style>
         <p:txBody>
-          <a:bodyPr lIns="73152" rIns="73152" rtlCol="0" anchor="ctr" tIns="27432" bIns="27432" wrap="square"/>
+          <a:bodyPr wrap="square" lIns="73152" tIns="27432" rIns="73152" bIns="27432" rtlCol="0" anchor="ctr"/>
           <a:lstStyle/>
           <a:p>
             <a:pPr algn="ctr">
@@ -3941,12 +3941,12 @@
               </a:spcAft>
             </a:pPr>
             <a:r>
-              <a:rPr sz="2200" b="0" lang="zh-CN">
+              <a:rPr lang="zh-CN" sz="2200" b="0">
                 <a:solidFill>
                   <a:srgbClr val="5A5A5A"/>
                 </a:solidFill>
-                <a:latin typeface="微软雅黑"/>
-                <a:ea typeface="微软雅黑"/>
+                <a:latin typeface="微软雅黑" panose="020B0503020204020204" charset="-122"/>
+                <a:ea typeface="微软雅黑" panose="020B0503020204020204" charset="-122"/>
               </a:rPr>
               <a:t>代表案例</a:t>
             </a:r>
@@ -3957,8 +3957,8 @@
                   <a:lumOff val="25000"/>
                 </a:schemeClr>
               </a:solidFill>
-              <a:latin typeface="微软雅黑" panose="020B0503020204020204" pitchFamily="34" charset="-122"/>
-              <a:ea typeface="微软雅黑" panose="020B0503020204020204" pitchFamily="34" charset="-122"/>
+              <a:latin typeface="微软雅黑" panose="020B0503020204020204" charset="-122"/>
+              <a:ea typeface="微软雅黑" panose="020B0503020204020204" charset="-122"/>
               <a:cs typeface="Calibri" panose="020F0502020204030204" pitchFamily="34" charset="0"/>
             </a:endParaRPr>
           </a:p>
@@ -4009,7 +4009,7 @@
           </a:fontRef>
         </p:style>
         <p:txBody>
-          <a:bodyPr lIns="73152" rIns="73152" rtlCol="0" anchor="ctr" tIns="27432" bIns="27432" wrap="square"/>
+          <a:bodyPr wrap="square" lIns="73152" tIns="27432" rIns="73152" bIns="27432" rtlCol="0" anchor="ctr"/>
           <a:lstStyle/>
           <a:p>
             <a:pPr algn="ctr">
@@ -4024,12 +4024,12 @@
               </a:spcAft>
             </a:pPr>
             <a:r>
-              <a:rPr sz="2200" b="0" lang="zh-CN">
+              <a:rPr lang="zh-CN" sz="2200" b="0">
                 <a:solidFill>
                   <a:srgbClr val="5A5A5A"/>
                 </a:solidFill>
-                <a:latin typeface="微软雅黑"/>
-                <a:ea typeface="微软雅黑"/>
+                <a:latin typeface="微软雅黑" panose="020B0503020204020204" charset="-122"/>
+                <a:ea typeface="微软雅黑" panose="020B0503020204020204" charset="-122"/>
               </a:rPr>
               <a:t>研究展望</a:t>
             </a:r>
@@ -4040,8 +4040,8 @@
                   <a:lumOff val="25000"/>
                 </a:schemeClr>
               </a:solidFill>
-              <a:latin typeface="微软雅黑" panose="020B0503020204020204" pitchFamily="34" charset="-122"/>
-              <a:ea typeface="微软雅黑" panose="020B0503020204020204" pitchFamily="34" charset="-122"/>
+              <a:latin typeface="微软雅黑" panose="020B0503020204020204" charset="-122"/>
+              <a:ea typeface="微软雅黑" panose="020B0503020204020204" charset="-122"/>
               <a:cs typeface="Calibri" panose="020F0502020204030204" pitchFamily="34" charset="0"/>
             </a:endParaRPr>
           </a:p>
@@ -4071,8 +4071,8 @@
                 <a:solidFill>
                   <a:schemeClr val="tx1"/>
                 </a:solidFill>
-                <a:latin typeface="微软雅黑" panose="020B0503020204020204" pitchFamily="34" charset="-122"/>
-                <a:ea typeface="微软雅黑" panose="020B0503020204020204" pitchFamily="34" charset="-122"/>
+                <a:latin typeface="微软雅黑" panose="020B0503020204020204" charset="-122"/>
+                <a:ea typeface="微软雅黑" panose="020B0503020204020204" charset="-122"/>
                 <a:cs typeface="Arial" panose="020B0604020202020204" pitchFamily="34" charset="0"/>
               </a:defRPr>
             </a:lvl1pPr>
@@ -6720,7 +6720,7 @@
 </p:sldMaster>
 </file>
 
-<file path=ppt/slides/slide4.xml><?xml version="1.0" encoding="utf-8"?>
+<file path=ppt/slides/slide1.xml><?xml version="1.0" encoding="utf-8"?>
 <p:sld xmlns:a="http://schemas.openxmlformats.org/drawingml/2006/main" xmlns:r="http://schemas.openxmlformats.org/officeDocument/2006/relationships" xmlns:p="http://schemas.openxmlformats.org/presentationml/2006/main" showMasterSp="0">
   <p:cSld>
     <p:spTree>
@@ -6782,7 +6782,7 @@
           </a:fontRef>
         </p:style>
         <p:txBody>
-          <a:bodyPr lIns="73152" rIns="73152" rtlCol="0" anchor="ctr" tIns="27432" bIns="27432" wrap="square"/>
+          <a:bodyPr wrap="square" lIns="73152" tIns="27432" rIns="73152" bIns="27432" rtlCol="0" anchor="ctr"/>
           <a:lstStyle/>
           <a:p>
             <a:pPr algn="ctr">
@@ -6797,12 +6797,12 @@
               </a:spcAft>
             </a:pPr>
             <a:r>
-              <a:rPr sz="2200" b="0" lang="zh-CN">
+              <a:rPr lang="zh-CN" sz="2200" b="0">
                 <a:solidFill>
                   <a:srgbClr val="5A5A5A"/>
                 </a:solidFill>
-                <a:latin typeface="微软雅黑"/>
-                <a:ea typeface="微软雅黑"/>
+                <a:latin typeface="微软雅黑" panose="020B0503020204020204" charset="-122"/>
+                <a:ea typeface="微软雅黑" panose="020B0503020204020204" charset="-122"/>
               </a:rPr>
               <a:t>课题方向</a:t>
             </a:r>
@@ -6813,8 +6813,8 @@
                   <a:lumOff val="25000"/>
                 </a:schemeClr>
               </a:solidFill>
-              <a:latin typeface="微软雅黑" panose="020B0503020204020204" pitchFamily="34" charset="-122"/>
-              <a:ea typeface="微软雅黑" panose="020B0503020204020204" pitchFamily="34" charset="-122"/>
+              <a:latin typeface="微软雅黑" panose="020B0503020204020204" charset="-122"/>
+              <a:ea typeface="微软雅黑" panose="020B0503020204020204" charset="-122"/>
               <a:cs typeface="Calibri" panose="020F0502020204030204" pitchFamily="34" charset="0"/>
             </a:endParaRPr>
           </a:p>
@@ -6865,7 +6865,7 @@
           </a:fontRef>
         </p:style>
         <p:txBody>
-          <a:bodyPr rtlCol="0" anchor="ctr" lIns="73152" rIns="73152" tIns="27432" bIns="27432" wrap="square"/>
+          <a:bodyPr wrap="square" lIns="73152" tIns="27432" rIns="73152" bIns="27432" rtlCol="0" anchor="ctr"/>
           <a:lstStyle/>
           <a:p>
             <a:pPr algn="ctr">
@@ -6880,12 +6880,12 @@
               </a:spcAft>
             </a:pPr>
             <a:r>
-              <a:rPr sz="2200" b="1" lang="zh-CN">
+              <a:rPr lang="zh-CN" sz="2200" b="1">
                 <a:solidFill>
                   <a:srgbClr val="FFFFFF"/>
                 </a:solidFill>
-                <a:latin typeface="微软雅黑"/>
-                <a:ea typeface="微软雅黑"/>
+                <a:latin typeface="微软雅黑" panose="020B0503020204020204" charset="-122"/>
+                <a:ea typeface="微软雅黑" panose="020B0503020204020204" charset="-122"/>
               </a:rPr>
               <a:t>技术原理</a:t>
             </a:r>
@@ -6893,8 +6893,8 @@
               <a:solidFill>
                 <a:schemeClr val="bg1"/>
               </a:solidFill>
-              <a:latin typeface="微软雅黑" panose="020B0503020204020204" pitchFamily="34" charset="-122"/>
-              <a:ea typeface="微软雅黑" panose="020B0503020204020204" pitchFamily="34" charset="-122"/>
+              <a:latin typeface="微软雅黑" panose="020B0503020204020204" charset="-122"/>
+              <a:ea typeface="微软雅黑" panose="020B0503020204020204" charset="-122"/>
               <a:cs typeface="Calibri" panose="020F0502020204030204" pitchFamily="34" charset="0"/>
             </a:endParaRPr>
           </a:p>
@@ -6945,7 +6945,7 @@
           </a:fontRef>
         </p:style>
         <p:txBody>
-          <a:bodyPr lIns="73152" rIns="73152" rtlCol="0" anchor="ctr" tIns="27432" bIns="27432" wrap="square"/>
+          <a:bodyPr wrap="square" lIns="73152" tIns="27432" rIns="73152" bIns="27432" rtlCol="0" anchor="ctr"/>
           <a:lstStyle/>
           <a:p>
             <a:pPr algn="ctr">
@@ -6960,12 +6960,12 @@
               </a:spcAft>
             </a:pPr>
             <a:r>
-              <a:rPr sz="2200" b="0" lang="zh-CN">
+              <a:rPr lang="zh-CN" sz="2200" b="0">
                 <a:solidFill>
                   <a:srgbClr val="5A5A5A"/>
                 </a:solidFill>
-                <a:latin typeface="微软雅黑"/>
-                <a:ea typeface="微软雅黑"/>
+                <a:latin typeface="微软雅黑" panose="020B0503020204020204" charset="-122"/>
+                <a:ea typeface="微软雅黑" panose="020B0503020204020204" charset="-122"/>
               </a:rPr>
               <a:t>代表案例</a:t>
             </a:r>
@@ -6976,8 +6976,8 @@
                   <a:lumOff val="25000"/>
                 </a:schemeClr>
               </a:solidFill>
-              <a:latin typeface="微软雅黑" panose="020B0503020204020204" pitchFamily="34" charset="-122"/>
-              <a:ea typeface="微软雅黑" panose="020B0503020204020204" pitchFamily="34" charset="-122"/>
+              <a:latin typeface="微软雅黑" panose="020B0503020204020204" charset="-122"/>
+              <a:ea typeface="微软雅黑" panose="020B0503020204020204" charset="-122"/>
               <a:cs typeface="Calibri" panose="020F0502020204030204" pitchFamily="34" charset="0"/>
             </a:endParaRPr>
           </a:p>
@@ -7028,7 +7028,7 @@
           </a:fontRef>
         </p:style>
         <p:txBody>
-          <a:bodyPr lIns="73152" rIns="73152" rtlCol="0" anchor="ctr" tIns="27432" bIns="27432" wrap="square"/>
+          <a:bodyPr wrap="square" lIns="73152" tIns="27432" rIns="73152" bIns="27432" rtlCol="0" anchor="ctr"/>
           <a:lstStyle/>
           <a:p>
             <a:pPr algn="ctr">
@@ -7043,12 +7043,12 @@
               </a:spcAft>
             </a:pPr>
             <a:r>
-              <a:rPr sz="2200" b="0" lang="zh-CN">
+              <a:rPr lang="zh-CN" sz="2200" b="0">
                 <a:solidFill>
                   <a:srgbClr val="5A5A5A"/>
                 </a:solidFill>
-                <a:latin typeface="微软雅黑"/>
-                <a:ea typeface="微软雅黑"/>
+                <a:latin typeface="微软雅黑" panose="020B0503020204020204" charset="-122"/>
+                <a:ea typeface="微软雅黑" panose="020B0503020204020204" charset="-122"/>
               </a:rPr>
               <a:t>研究展望</a:t>
             </a:r>
@@ -7059,8 +7059,8 @@
                   <a:lumOff val="25000"/>
                 </a:schemeClr>
               </a:solidFill>
-              <a:latin typeface="微软雅黑" panose="020B0503020204020204" pitchFamily="34" charset="-122"/>
-              <a:ea typeface="微软雅黑" panose="020B0503020204020204" pitchFamily="34" charset="-122"/>
+              <a:latin typeface="微软雅黑" panose="020B0503020204020204" charset="-122"/>
+              <a:ea typeface="微软雅黑" panose="020B0503020204020204" charset="-122"/>
               <a:cs typeface="Calibri" panose="020F0502020204030204" pitchFamily="34" charset="0"/>
             </a:endParaRPr>
           </a:p>
@@ -7075,8 +7075,8 @@
           <p:nvPr/>
         </p:nvPicPr>
         <p:blipFill>
-          <a:blip r:embed="rId3"/>
-          <a:srcRect l="6578" r="7126" t="24836" b="24071"/>
+          <a:blip r:embed="rId1"/>
+          <a:srcRect l="6578" t="24836" r="7126" b="24071"/>
           <a:stretch>
             <a:fillRect/>
           </a:stretch>
@@ -7142,10 +7142,10 @@
           </a:fontRef>
         </p:style>
         <p:txBody>
-          <a:bodyPr rtlCol="0" anchor="ctr" lIns="73152" rIns="73152" tIns="27432" bIns="27432" wrap="square"/>
-          <a:lstStyle/>
-          <a:p>
-            <a:pPr defTabSz="2400300" algn="l">
+          <a:bodyPr wrap="square" lIns="73152" tIns="27432" rIns="73152" bIns="27432" rtlCol="0" anchor="ctr"/>
+          <a:lstStyle/>
+          <a:p>
+            <a:pPr algn="l" defTabSz="2400300">
               <a:lnSpc>
                 <a:spcPct val="115000"/>
               </a:lnSpc>
@@ -7157,21 +7157,21 @@
               </a:spcAft>
             </a:pPr>
             <a:r>
-              <a:rPr sz="2600" b="1" lang="zh-CN">
+              <a:rPr lang="zh-CN" sz="2600" b="1">
                 <a:solidFill>
                   <a:srgbClr val="383838"/>
                 </a:solidFill>
-                <a:latin typeface="微软雅黑"/>
-                <a:ea typeface="微软雅黑"/>
+                <a:latin typeface="微软雅黑" panose="020B0503020204020204" charset="-122"/>
+                <a:ea typeface="微软雅黑" panose="020B0503020204020204" charset="-122"/>
               </a:rPr>
-              <a:t>Agent Harness 原理：把模型与工具组织成设计闭环</a:t>
+              <a:t>光芯片设计Harness ：把模型与工具组织成设计闭环</a:t>
             </a:r>
             <a:endParaRPr lang="zh-CN" altLang="en-US" sz="2800" b="1" dirty="0">
               <a:solidFill>
                 <a:schemeClr val="tx1"/>
               </a:solidFill>
-              <a:latin typeface="微软雅黑" panose="020B0503020204020204" pitchFamily="34" charset="-122"/>
-              <a:ea typeface="微软雅黑" panose="020B0503020204020204" pitchFamily="34" charset="-122"/>
+              <a:latin typeface="微软雅黑" panose="020B0503020204020204" charset="-122"/>
+              <a:ea typeface="微软雅黑" panose="020B0503020204020204" charset="-122"/>
             </a:endParaRPr>
           </a:p>
         </p:txBody>
@@ -7193,7 +7193,7 @@
           <a:noFill/>
         </p:spPr>
         <p:txBody>
-          <a:bodyPr wrap="square" lIns="73152" rIns="73152" tIns="27432" bIns="27432" anchor="ctr">
+          <a:bodyPr wrap="square" lIns="73152" tIns="27432" rIns="73152" bIns="27432" anchor="ctr">
             <a:spAutoFit/>
           </a:bodyPr>
           <a:lstStyle/>
@@ -7210,15 +7210,22 @@
               </a:spcAft>
             </a:pPr>
             <a:r>
-              <a:rPr sz="1600" b="0" lang="zh-CN">
+              <a:rPr lang="zh-CN" sz="1600" b="0">
                 <a:solidFill>
                   <a:srgbClr val="5A5A5A"/>
                 </a:solidFill>
-                <a:latin typeface="微软雅黑"/>
-                <a:ea typeface="微软雅黑"/>
+                <a:latin typeface="微软雅黑" panose="020B0503020204020204" charset="-122"/>
+                <a:ea typeface="微软雅黑" panose="020B0503020204020204" charset="-122"/>
               </a:rPr>
               <a:t>围绕大语言模型组织需求解析、工具执行、结果评价与状态记录</a:t>
             </a:r>
+            <a:endParaRPr lang="zh-CN" sz="1600" b="0">
+              <a:solidFill>
+                <a:srgbClr val="5A5A5A"/>
+              </a:solidFill>
+              <a:latin typeface="微软雅黑" panose="020B0503020204020204" charset="-122"/>
+              <a:ea typeface="微软雅黑" panose="020B0503020204020204" charset="-122"/>
+            </a:endParaRPr>
           </a:p>
         </p:txBody>
       </p:sp>
@@ -7319,7 +7326,7 @@
           </a:fontRef>
         </p:style>
         <p:txBody>
-          <a:bodyPr lIns="73152" tIns="27432" rIns="73152" bIns="27432" rtlCol="0" anchor="ctr" wrap="square"/>
+          <a:bodyPr wrap="square" lIns="73152" tIns="27432" rIns="73152" bIns="27432" rtlCol="0" anchor="ctr"/>
           <a:lstStyle/>
           <a:p>
             <a:pPr algn="ctr">
@@ -7334,12 +7341,12 @@
               </a:spcAft>
             </a:pPr>
             <a:r>
-              <a:rPr sz="1800" b="1" lang="zh-CN">
+              <a:rPr lang="zh-CN" sz="1800" b="1">
                 <a:solidFill>
                   <a:srgbClr val="FFFFFF"/>
                 </a:solidFill>
-                <a:latin typeface="微软雅黑"/>
-                <a:ea typeface="微软雅黑"/>
+                <a:latin typeface="微软雅黑" panose="020B0503020204020204" charset="-122"/>
+                <a:ea typeface="微软雅黑" panose="020B0503020204020204" charset="-122"/>
               </a:rPr>
               <a:t>设计需求</a:t>
             </a:r>
@@ -7347,8 +7354,8 @@
               <a:solidFill>
                 <a:schemeClr val="bg1"/>
               </a:solidFill>
-              <a:latin typeface="微软雅黑" panose="020B0503020204020204" pitchFamily="34" charset="-122"/>
-              <a:ea typeface="微软雅黑" panose="020B0503020204020204" pitchFamily="34" charset="-122"/>
+              <a:latin typeface="微软雅黑" panose="020B0503020204020204" charset="-122"/>
+              <a:ea typeface="微软雅黑" panose="020B0503020204020204" charset="-122"/>
             </a:endParaRPr>
           </a:p>
         </p:txBody>
@@ -7361,8 +7368,8 @@
         </p:nvSpPr>
         <p:spPr>
           <a:xfrm>
-            <a:off x="704088" y="3337560"/>
-            <a:ext cx="2112264" cy="685800"/>
+            <a:off x="704088" y="3344863"/>
+            <a:ext cx="2112264" cy="671195"/>
           </a:xfrm>
           <a:prstGeom prst="rect">
             <a:avLst/>
@@ -7370,7 +7377,7 @@
           <a:noFill/>
         </p:spPr>
         <p:txBody>
-          <a:bodyPr wrap="square" lIns="73152" rIns="73152" tIns="27432" bIns="27432" anchor="ctr">
+          <a:bodyPr wrap="square" lIns="73152" tIns="27432" rIns="73152" bIns="27432" anchor="ctr">
             <a:spAutoFit/>
           </a:bodyPr>
           <a:lstStyle/>
@@ -7387,15 +7394,22 @@
               </a:spcAft>
             </a:pPr>
             <a:r>
-              <a:rPr sz="1600" b="0" lang="zh-CN">
+              <a:rPr lang="zh-CN" sz="1600" b="0">
                 <a:solidFill>
                   <a:srgbClr val="5A5A5A"/>
                 </a:solidFill>
-                <a:latin typeface="微软雅黑"/>
-                <a:ea typeface="微软雅黑"/>
+                <a:latin typeface="微软雅黑" panose="020B0503020204020204" charset="-122"/>
+                <a:ea typeface="微软雅黑" panose="020B0503020204020204" charset="-122"/>
               </a:rPr>
-              <a:t>目标性能与约束</a:t>
-            </a:r>
+              <a:t>光芯片目标性能</a:t>
+            </a:r>
+            <a:endParaRPr lang="zh-CN" sz="1600" b="0">
+              <a:solidFill>
+                <a:srgbClr val="5A5A5A"/>
+              </a:solidFill>
+              <a:latin typeface="微软雅黑" panose="020B0503020204020204" charset="-122"/>
+              <a:ea typeface="微软雅黑" panose="020B0503020204020204" charset="-122"/>
+            </a:endParaRPr>
           </a:p>
           <a:p>
             <a:pPr algn="ctr">
@@ -7410,15 +7424,22 @@
               </a:spcAft>
             </a:pPr>
             <a:r>
-              <a:rPr sz="1600" b="0" lang="zh-CN">
+              <a:rPr lang="zh-CN" sz="1600" b="0">
                 <a:solidFill>
                   <a:srgbClr val="5A5A5A"/>
                 </a:solidFill>
-                <a:latin typeface="微软雅黑"/>
-                <a:ea typeface="微软雅黑"/>
+                <a:latin typeface="微软雅黑" panose="020B0503020204020204" charset="-122"/>
+                <a:ea typeface="微软雅黑" panose="020B0503020204020204" charset="-122"/>
               </a:rPr>
               <a:t>结构与参数范围</a:t>
             </a:r>
+            <a:endParaRPr lang="zh-CN" sz="1600" b="0">
+              <a:solidFill>
+                <a:srgbClr val="5A5A5A"/>
+              </a:solidFill>
+              <a:latin typeface="微软雅黑" panose="020B0503020204020204" charset="-122"/>
+              <a:ea typeface="微软雅黑" panose="020B0503020204020204" charset="-122"/>
+            </a:endParaRPr>
           </a:p>
         </p:txBody>
       </p:sp>
@@ -7555,7 +7576,7 @@
           </a:fontRef>
         </p:style>
         <p:txBody>
-          <a:bodyPr lIns="73152" tIns="27432" rIns="73152" bIns="27432" rtlCol="0" anchor="ctr" wrap="square"/>
+          <a:bodyPr wrap="square" lIns="73152" tIns="27432" rIns="73152" bIns="27432" rtlCol="0" anchor="ctr"/>
           <a:lstStyle/>
           <a:p>
             <a:pPr algn="ctr">
@@ -7570,12 +7591,12 @@
               </a:spcAft>
             </a:pPr>
             <a:r>
-              <a:rPr sz="1800" b="1" lang="zh-CN">
+              <a:rPr lang="zh-CN" sz="1800" b="1">
                 <a:solidFill>
                   <a:srgbClr val="FFFFFF"/>
                 </a:solidFill>
-                <a:latin typeface="微软雅黑"/>
-                <a:ea typeface="微软雅黑"/>
+                <a:latin typeface="微软雅黑" panose="020B0503020204020204" charset="-122"/>
+                <a:ea typeface="微软雅黑" panose="020B0503020204020204" charset="-122"/>
               </a:rPr>
               <a:t>Agent 规划与决策</a:t>
             </a:r>
@@ -7583,8 +7604,8 @@
               <a:solidFill>
                 <a:schemeClr val="bg1"/>
               </a:solidFill>
-              <a:latin typeface="微软雅黑" panose="020B0503020204020204" pitchFamily="34" charset="-122"/>
-              <a:ea typeface="微软雅黑" panose="020B0503020204020204" pitchFamily="34" charset="-122"/>
+              <a:latin typeface="微软雅黑" panose="020B0503020204020204" charset="-122"/>
+              <a:ea typeface="微软雅黑" panose="020B0503020204020204" charset="-122"/>
             </a:endParaRPr>
           </a:p>
         </p:txBody>
@@ -7606,7 +7627,7 @@
           <a:noFill/>
         </p:spPr>
         <p:txBody>
-          <a:bodyPr wrap="square" lIns="73152" rIns="73152" tIns="27432" bIns="27432" anchor="ctr">
+          <a:bodyPr wrap="square" lIns="73152" tIns="27432" rIns="73152" bIns="27432" anchor="ctr">
             <a:spAutoFit/>
           </a:bodyPr>
           <a:lstStyle/>
@@ -7623,15 +7644,22 @@
               </a:spcAft>
             </a:pPr>
             <a:r>
-              <a:rPr sz="1600" b="0" lang="zh-CN">
+              <a:rPr lang="zh-CN" sz="1600" b="0">
                 <a:solidFill>
                   <a:srgbClr val="5A5A5A"/>
                 </a:solidFill>
-                <a:latin typeface="微软雅黑"/>
-                <a:ea typeface="微软雅黑"/>
+                <a:latin typeface="微软雅黑" panose="020B0503020204020204" charset="-122"/>
+                <a:ea typeface="微软雅黑" panose="020B0503020204020204" charset="-122"/>
               </a:rPr>
               <a:t>解析需求 / 生成候选</a:t>
             </a:r>
+            <a:endParaRPr lang="zh-CN" sz="1600" b="0">
+              <a:solidFill>
+                <a:srgbClr val="5A5A5A"/>
+              </a:solidFill>
+              <a:latin typeface="微软雅黑" panose="020B0503020204020204" charset="-122"/>
+              <a:ea typeface="微软雅黑" panose="020B0503020204020204" charset="-122"/>
+            </a:endParaRPr>
           </a:p>
           <a:p>
             <a:pPr algn="ctr">
@@ -7646,15 +7674,22 @@
               </a:spcAft>
             </a:pPr>
             <a:r>
-              <a:rPr sz="1600" b="0" lang="zh-CN">
+              <a:rPr lang="zh-CN" sz="1600" b="0">
                 <a:solidFill>
                   <a:srgbClr val="5A5A5A"/>
                 </a:solidFill>
-                <a:latin typeface="微软雅黑"/>
-                <a:ea typeface="微软雅黑"/>
+                <a:latin typeface="微软雅黑" panose="020B0503020204020204" charset="-122"/>
+                <a:ea typeface="微软雅黑" panose="020B0503020204020204" charset="-122"/>
               </a:rPr>
               <a:t>诊断结果 / 选择动作</a:t>
             </a:r>
+            <a:endParaRPr lang="zh-CN" sz="1600" b="0">
+              <a:solidFill>
+                <a:srgbClr val="5A5A5A"/>
+              </a:solidFill>
+              <a:latin typeface="微软雅黑" panose="020B0503020204020204" charset="-122"/>
+              <a:ea typeface="微软雅黑" panose="020B0503020204020204" charset="-122"/>
+            </a:endParaRPr>
           </a:p>
         </p:txBody>
       </p:sp>
@@ -7791,7 +7826,7 @@
           </a:fontRef>
         </p:style>
         <p:txBody>
-          <a:bodyPr lIns="73152" tIns="27432" rIns="73152" bIns="27432" rtlCol="0" anchor="ctr" wrap="square"/>
+          <a:bodyPr wrap="square" lIns="73152" tIns="27432" rIns="73152" bIns="27432" rtlCol="0" anchor="ctr"/>
           <a:lstStyle/>
           <a:p>
             <a:pPr algn="ctr">
@@ -7806,12 +7841,12 @@
               </a:spcAft>
             </a:pPr>
             <a:r>
-              <a:rPr sz="1800" b="1" lang="zh-CN">
+              <a:rPr lang="zh-CN" sz="1800" b="1">
                 <a:solidFill>
                   <a:srgbClr val="FFFFFF"/>
                 </a:solidFill>
-                <a:latin typeface="微软雅黑"/>
-                <a:ea typeface="微软雅黑"/>
+                <a:latin typeface="微软雅黑" panose="020B0503020204020204" charset="-122"/>
+                <a:ea typeface="微软雅黑" panose="020B0503020204020204" charset="-122"/>
               </a:rPr>
               <a:t>设计与仿真工具</a:t>
             </a:r>
@@ -7819,8 +7854,8 @@
               <a:solidFill>
                 <a:schemeClr val="bg1"/>
               </a:solidFill>
-              <a:latin typeface="微软雅黑" panose="020B0503020204020204" pitchFamily="34" charset="-122"/>
-              <a:ea typeface="微软雅黑" panose="020B0503020204020204" pitchFamily="34" charset="-122"/>
+              <a:latin typeface="微软雅黑" panose="020B0503020204020204" charset="-122"/>
+              <a:ea typeface="微软雅黑" panose="020B0503020204020204" charset="-122"/>
             </a:endParaRPr>
           </a:p>
         </p:txBody>
@@ -7833,8 +7868,8 @@
         </p:nvSpPr>
         <p:spPr>
           <a:xfrm>
-            <a:off x="6483096" y="3337560"/>
-            <a:ext cx="2112264" cy="685800"/>
+            <a:off x="6483096" y="3344863"/>
+            <a:ext cx="2112264" cy="671195"/>
           </a:xfrm>
           <a:prstGeom prst="rect">
             <a:avLst/>
@@ -7842,7 +7877,7 @@
           <a:noFill/>
         </p:spPr>
         <p:txBody>
-          <a:bodyPr wrap="square" lIns="73152" rIns="73152" tIns="27432" bIns="27432" anchor="ctr">
+          <a:bodyPr wrap="square" lIns="73152" tIns="27432" rIns="73152" bIns="27432" anchor="ctr">
             <a:spAutoFit/>
           </a:bodyPr>
           <a:lstStyle/>
@@ -7859,15 +7894,22 @@
               </a:spcAft>
             </a:pPr>
             <a:r>
-              <a:rPr sz="1600" b="0" lang="zh-CN">
+              <a:rPr lang="zh-CN" sz="1600" b="0">
                 <a:solidFill>
                   <a:srgbClr val="5A5A5A"/>
                 </a:solidFill>
-                <a:latin typeface="微软雅黑"/>
-                <a:ea typeface="微软雅黑"/>
+                <a:latin typeface="微软雅黑" panose="020B0503020204020204" charset="-122"/>
+                <a:ea typeface="微软雅黑" panose="020B0503020204020204" charset="-122"/>
               </a:rPr>
-              <a:t>CAD / 电磁求解器</a:t>
-            </a:r>
+              <a:t>电磁求解器</a:t>
+            </a:r>
+            <a:endParaRPr lang="zh-CN" sz="1600" b="0">
+              <a:solidFill>
+                <a:srgbClr val="5A5A5A"/>
+              </a:solidFill>
+              <a:latin typeface="微软雅黑" panose="020B0503020204020204" charset="-122"/>
+              <a:ea typeface="微软雅黑" panose="020B0503020204020204" charset="-122"/>
+            </a:endParaRPr>
           </a:p>
           <a:p>
             <a:pPr algn="ctr">
@@ -7882,15 +7924,22 @@
               </a:spcAft>
             </a:pPr>
             <a:r>
-              <a:rPr sz="1600" b="0" lang="zh-CN">
+              <a:rPr lang="zh-CN" sz="1600" b="0">
                 <a:solidFill>
                   <a:srgbClr val="5A5A5A"/>
                 </a:solidFill>
-                <a:latin typeface="微软雅黑"/>
-                <a:ea typeface="微软雅黑"/>
+                <a:latin typeface="微软雅黑" panose="020B0503020204020204" charset="-122"/>
+                <a:ea typeface="微软雅黑" panose="020B0503020204020204" charset="-122"/>
               </a:rPr>
               <a:t>输出结构、光谱和场</a:t>
             </a:r>
+            <a:endParaRPr lang="zh-CN" sz="1600" b="0">
+              <a:solidFill>
+                <a:srgbClr val="5A5A5A"/>
+              </a:solidFill>
+              <a:latin typeface="微软雅黑" panose="020B0503020204020204" charset="-122"/>
+              <a:ea typeface="微软雅黑" panose="020B0503020204020204" charset="-122"/>
+            </a:endParaRPr>
           </a:p>
         </p:txBody>
       </p:sp>
@@ -8027,7 +8076,7 @@
           </a:fontRef>
         </p:style>
         <p:txBody>
-          <a:bodyPr lIns="73152" tIns="27432" rIns="73152" bIns="27432" rtlCol="0" anchor="ctr" wrap="square"/>
+          <a:bodyPr wrap="square" lIns="73152" tIns="27432" rIns="73152" bIns="27432" rtlCol="0" anchor="ctr"/>
           <a:lstStyle/>
           <a:p>
             <a:pPr algn="ctr">
@@ -8042,12 +8091,12 @@
               </a:spcAft>
             </a:pPr>
             <a:r>
-              <a:rPr sz="1800" b="1" lang="zh-CN">
+              <a:rPr lang="zh-CN" sz="1800" b="1">
                 <a:solidFill>
                   <a:srgbClr val="FFFFFF"/>
                 </a:solidFill>
-                <a:latin typeface="微软雅黑"/>
-                <a:ea typeface="微软雅黑"/>
+                <a:latin typeface="微软雅黑" panose="020B0503020204020204" charset="-122"/>
+                <a:ea typeface="微软雅黑" panose="020B0503020204020204" charset="-122"/>
               </a:rPr>
               <a:t>评价与验证</a:t>
             </a:r>
@@ -8055,8 +8104,8 @@
               <a:solidFill>
                 <a:schemeClr val="bg1"/>
               </a:solidFill>
-              <a:latin typeface="微软雅黑" panose="020B0503020204020204" pitchFamily="34" charset="-122"/>
-              <a:ea typeface="微软雅黑" panose="020B0503020204020204" pitchFamily="34" charset="-122"/>
+              <a:latin typeface="微软雅黑" panose="020B0503020204020204" charset="-122"/>
+              <a:ea typeface="微软雅黑" panose="020B0503020204020204" charset="-122"/>
             </a:endParaRPr>
           </a:p>
         </p:txBody>
@@ -8078,7 +8127,7 @@
           <a:noFill/>
         </p:spPr>
         <p:txBody>
-          <a:bodyPr wrap="square" lIns="73152" rIns="73152" tIns="27432" bIns="27432" anchor="ctr">
+          <a:bodyPr wrap="square" lIns="73152" tIns="27432" rIns="73152" bIns="27432" anchor="ctr">
             <a:spAutoFit/>
           </a:bodyPr>
           <a:lstStyle/>
@@ -8095,15 +8144,22 @@
               </a:spcAft>
             </a:pPr>
             <a:r>
-              <a:rPr sz="1600" b="0" lang="zh-CN">
+              <a:rPr lang="zh-CN" sz="1600" b="0">
                 <a:solidFill>
                   <a:srgbClr val="5A5A5A"/>
                 </a:solidFill>
-                <a:latin typeface="微软雅黑"/>
-                <a:ea typeface="微软雅黑"/>
+                <a:latin typeface="微软雅黑" panose="020B0503020204020204" charset="-122"/>
+                <a:ea typeface="微软雅黑" panose="020B0503020204020204" charset="-122"/>
               </a:rPr>
               <a:t>计算指标 / 检查规则</a:t>
             </a:r>
+            <a:endParaRPr lang="zh-CN" sz="1600" b="0">
+              <a:solidFill>
+                <a:srgbClr val="5A5A5A"/>
+              </a:solidFill>
+              <a:latin typeface="微软雅黑" panose="020B0503020204020204" charset="-122"/>
+              <a:ea typeface="微软雅黑" panose="020B0503020204020204" charset="-122"/>
+            </a:endParaRPr>
           </a:p>
           <a:p>
             <a:pPr algn="ctr">
@@ -8118,15 +8174,22 @@
               </a:spcAft>
             </a:pPr>
             <a:r>
-              <a:rPr sz="1600" b="0" lang="zh-CN">
+              <a:rPr lang="zh-CN" sz="1600" b="0">
                 <a:solidFill>
                   <a:srgbClr val="5A5A5A"/>
                 </a:solidFill>
-                <a:latin typeface="微软雅黑"/>
-                <a:ea typeface="微软雅黑"/>
+                <a:latin typeface="微软雅黑" panose="020B0503020204020204" charset="-122"/>
+                <a:ea typeface="微软雅黑" panose="020B0503020204020204" charset="-122"/>
               </a:rPr>
               <a:t>判定达标或继续迭代</a:t>
             </a:r>
+            <a:endParaRPr lang="zh-CN" sz="1600" b="0">
+              <a:solidFill>
+                <a:srgbClr val="5A5A5A"/>
+              </a:solidFill>
+              <a:latin typeface="微软雅黑" panose="020B0503020204020204" charset="-122"/>
+              <a:ea typeface="微软雅黑" panose="020B0503020204020204" charset="-122"/>
+            </a:endParaRPr>
           </a:p>
         </p:txBody>
       </p:sp>
@@ -8253,7 +8316,7 @@
           <a:noFill/>
         </p:spPr>
         <p:txBody>
-          <a:bodyPr wrap="square" lIns="73152" rIns="73152" tIns="27432" bIns="27432" anchor="ctr">
+          <a:bodyPr wrap="square" lIns="73152" tIns="27432" rIns="73152" bIns="27432" anchor="ctr">
             <a:spAutoFit/>
           </a:bodyPr>
           <a:lstStyle/>
@@ -8270,15 +8333,22 @@
               </a:spcAft>
             </a:pPr>
             <a:r>
-              <a:rPr sz="1800" b="1" lang="zh-CN">
+              <a:rPr lang="zh-CN" sz="1800" b="1">
                 <a:solidFill>
                   <a:srgbClr val="006579"/>
                 </a:solidFill>
-                <a:latin typeface="微软雅黑"/>
-                <a:ea typeface="微软雅黑"/>
+                <a:latin typeface="微软雅黑" panose="020B0503020204020204" charset="-122"/>
+                <a:ea typeface="微软雅黑" panose="020B0503020204020204" charset="-122"/>
               </a:rPr>
               <a:t>数值指标、约束检查与执行反馈</a:t>
             </a:r>
+            <a:endParaRPr lang="zh-CN" sz="1800" b="1">
+              <a:solidFill>
+                <a:srgbClr val="006579"/>
+              </a:solidFill>
+              <a:latin typeface="微软雅黑" panose="020B0503020204020204" charset="-122"/>
+              <a:ea typeface="微软雅黑" panose="020B0503020204020204" charset="-122"/>
+            </a:endParaRPr>
           </a:p>
         </p:txBody>
       </p:sp>
@@ -8299,7 +8369,7 @@
           <a:noFill/>
         </p:spPr>
         <p:txBody>
-          <a:bodyPr wrap="square" lIns="73152" rIns="73152" tIns="27432" bIns="27432" anchor="ctr">
+          <a:bodyPr wrap="square" lIns="73152" tIns="27432" rIns="73152" bIns="27432" anchor="ctr">
             <a:spAutoFit/>
           </a:bodyPr>
           <a:lstStyle/>
@@ -8316,15 +8386,22 @@
               </a:spcAft>
             </a:pPr>
             <a:r>
-              <a:rPr sz="1600" b="0" lang="zh-CN">
+              <a:rPr lang="zh-CN" sz="1600" b="0">
                 <a:solidFill>
                   <a:srgbClr val="5A5A5A"/>
                 </a:solidFill>
-                <a:latin typeface="微软雅黑"/>
-                <a:ea typeface="微软雅黑"/>
+                <a:latin typeface="微软雅黑" panose="020B0503020204020204" charset="-122"/>
+                <a:ea typeface="微软雅黑" panose="020B0503020204020204" charset="-122"/>
               </a:rPr>
               <a:t>状态与设计轨迹持续记录</a:t>
             </a:r>
+            <a:endParaRPr lang="zh-CN" sz="1600" b="0">
+              <a:solidFill>
+                <a:srgbClr val="5A5A5A"/>
+              </a:solidFill>
+              <a:latin typeface="微软雅黑" panose="020B0503020204020204" charset="-122"/>
+              <a:ea typeface="微软雅黑" panose="020B0503020204020204" charset="-122"/>
+            </a:endParaRPr>
           </a:p>
         </p:txBody>
       </p:sp>
@@ -8364,7 +8441,7 @@
           </a:fontRef>
         </p:style>
         <p:txBody>
-          <a:bodyPr rtlCol="0" anchor="ctr" lIns="73152" rIns="73152" tIns="27432" bIns="27432" wrap="square"/>
+          <a:bodyPr wrap="square" lIns="73152" tIns="27432" rIns="73152" bIns="27432" rtlCol="0" anchor="ctr"/>
           <a:lstStyle/>
           <a:p>
             <a:pPr algn="ctr">
@@ -8379,15 +8456,22 @@
               </a:spcAft>
             </a:pPr>
             <a:r>
-              <a:rPr sz="1800" b="1" lang="zh-CN">
+              <a:rPr lang="zh-CN" sz="1800" b="1">
                 <a:solidFill>
                   <a:srgbClr val="FFFFFF"/>
                 </a:solidFill>
-                <a:latin typeface="微软雅黑"/>
-                <a:ea typeface="微软雅黑"/>
+                <a:latin typeface="微软雅黑" panose="020B0503020204020204" charset="-122"/>
+                <a:ea typeface="微软雅黑" panose="020B0503020204020204" charset="-122"/>
               </a:rPr>
               <a:t>研究关注：从仿真结果形成可检验的物理诊断与设计动作</a:t>
             </a:r>
+            <a:endParaRPr lang="zh-CN" sz="1800" b="1">
+              <a:solidFill>
+                <a:srgbClr val="FFFFFF"/>
+              </a:solidFill>
+              <a:latin typeface="微软雅黑" panose="020B0503020204020204" charset="-122"/>
+              <a:ea typeface="微软雅黑" panose="020B0503020204020204" charset="-122"/>
+            </a:endParaRPr>
           </a:p>
         </p:txBody>
       </p:sp>
@@ -8408,7 +8492,7 @@
           <a:noFill/>
         </p:spPr>
         <p:txBody>
-          <a:bodyPr wrap="square" lIns="73152" rIns="73152" tIns="27432" bIns="27432" anchor="ctr">
+          <a:bodyPr wrap="square" lIns="73152" tIns="27432" rIns="73152" bIns="27432" anchor="ctr">
             <a:spAutoFit/>
           </a:bodyPr>
           <a:lstStyle/>
@@ -8425,15 +8509,22 @@
               </a:spcAft>
             </a:pPr>
             <a:r>
-              <a:rPr sz="900" b="0" lang="zh-CN">
+              <a:rPr lang="zh-CN" sz="900" b="0">
                 <a:solidFill>
                   <a:srgbClr val="5A5A5A"/>
                 </a:solidFill>
-                <a:latin typeface="微软雅黑"/>
-                <a:ea typeface="微软雅黑"/>
+                <a:latin typeface="微软雅黑" panose="020B0503020204020204" charset="-122"/>
+                <a:ea typeface="微软雅黑" panose="020B0503020204020204" charset="-122"/>
               </a:rPr>
               <a:t>概念原理示意；依据 TASK-007 候选方向材料 §3–4。未表示已实现系统。</a:t>
             </a:r>
+            <a:endParaRPr lang="zh-CN" sz="900" b="0">
+              <a:solidFill>
+                <a:srgbClr val="5A5A5A"/>
+              </a:solidFill>
+              <a:latin typeface="微软雅黑" panose="020B0503020204020204" charset="-122"/>
+              <a:ea typeface="微软雅黑" panose="020B0503020204020204" charset="-122"/>
+            </a:endParaRPr>
           </a:p>
         </p:txBody>
       </p:sp>
@@ -8445,7 +8536,7 @@
 </p:sld>
 </file>
 
-<file path=ppt/slides/slide6.xml><?xml version="1.0" encoding="utf-8"?>
+<file path=ppt/slides/slide2.xml><?xml version="1.0" encoding="utf-8"?>
 <p:sld xmlns:a="http://schemas.openxmlformats.org/drawingml/2006/main" xmlns:r="http://schemas.openxmlformats.org/officeDocument/2006/relationships" xmlns:p="http://schemas.openxmlformats.org/presentationml/2006/main" showMasterSp="0">
   <p:cSld>
     <p:spTree>
@@ -8507,7 +8598,7 @@
           </a:fontRef>
         </p:style>
         <p:txBody>
-          <a:bodyPr lIns="73152" rIns="73152" rtlCol="0" anchor="ctr" tIns="27432" bIns="27432" wrap="square"/>
+          <a:bodyPr wrap="square" lIns="73152" tIns="27432" rIns="73152" bIns="27432" rtlCol="0" anchor="ctr"/>
           <a:lstStyle/>
           <a:p>
             <a:pPr algn="ctr">
@@ -8522,12 +8613,12 @@
               </a:spcAft>
             </a:pPr>
             <a:r>
-              <a:rPr sz="2200" b="0" lang="zh-CN">
+              <a:rPr lang="zh-CN" sz="2200" b="0">
                 <a:solidFill>
                   <a:srgbClr val="5A5A5A"/>
                 </a:solidFill>
-                <a:latin typeface="微软雅黑"/>
-                <a:ea typeface="微软雅黑"/>
+                <a:latin typeface="微软雅黑" panose="020B0503020204020204" charset="-122"/>
+                <a:ea typeface="微软雅黑" panose="020B0503020204020204" charset="-122"/>
               </a:rPr>
               <a:t>课题方向</a:t>
             </a:r>
@@ -8538,8 +8629,8 @@
                   <a:lumOff val="25000"/>
                 </a:schemeClr>
               </a:solidFill>
-              <a:latin typeface="微软雅黑" panose="020B0503020204020204" pitchFamily="34" charset="-122"/>
-              <a:ea typeface="微软雅黑" panose="020B0503020204020204" pitchFamily="34" charset="-122"/>
+              <a:latin typeface="微软雅黑" panose="020B0503020204020204" charset="-122"/>
+              <a:ea typeface="微软雅黑" panose="020B0503020204020204" charset="-122"/>
               <a:cs typeface="Calibri" panose="020F0502020204030204" pitchFamily="34" charset="0"/>
             </a:endParaRPr>
           </a:p>
@@ -8590,7 +8681,7 @@
           </a:fontRef>
         </p:style>
         <p:txBody>
-          <a:bodyPr lIns="73152" rIns="73152" rtlCol="0" anchor="ctr" tIns="27432" bIns="27432" wrap="square"/>
+          <a:bodyPr wrap="square" lIns="73152" tIns="27432" rIns="73152" bIns="27432" rtlCol="0" anchor="ctr"/>
           <a:lstStyle/>
           <a:p>
             <a:pPr algn="ctr">
@@ -8605,12 +8696,12 @@
               </a:spcAft>
             </a:pPr>
             <a:r>
-              <a:rPr sz="2200" b="0" lang="zh-CN">
+              <a:rPr lang="zh-CN" sz="2200" b="0">
                 <a:solidFill>
                   <a:srgbClr val="5A5A5A"/>
                 </a:solidFill>
-                <a:latin typeface="微软雅黑"/>
-                <a:ea typeface="微软雅黑"/>
+                <a:latin typeface="微软雅黑" panose="020B0503020204020204" charset="-122"/>
+                <a:ea typeface="微软雅黑" panose="020B0503020204020204" charset="-122"/>
               </a:rPr>
               <a:t>技术原理</a:t>
             </a:r>
@@ -8621,8 +8712,8 @@
                   <a:lumOff val="25000"/>
                 </a:schemeClr>
               </a:solidFill>
-              <a:latin typeface="微软雅黑" panose="020B0503020204020204" pitchFamily="34" charset="-122"/>
-              <a:ea typeface="微软雅黑" panose="020B0503020204020204" pitchFamily="34" charset="-122"/>
+              <a:latin typeface="微软雅黑" panose="020B0503020204020204" charset="-122"/>
+              <a:ea typeface="微软雅黑" panose="020B0503020204020204" charset="-122"/>
               <a:cs typeface="Calibri" panose="020F0502020204030204" pitchFamily="34" charset="0"/>
             </a:endParaRPr>
           </a:p>
@@ -8673,7 +8764,7 @@
           </a:fontRef>
         </p:style>
         <p:txBody>
-          <a:bodyPr rtlCol="0" anchor="ctr" lIns="73152" rIns="73152" tIns="27432" bIns="27432" wrap="square"/>
+          <a:bodyPr wrap="square" lIns="73152" tIns="27432" rIns="73152" bIns="27432" rtlCol="0" anchor="ctr"/>
           <a:lstStyle/>
           <a:p>
             <a:pPr algn="ctr">
@@ -8688,12 +8779,12 @@
               </a:spcAft>
             </a:pPr>
             <a:r>
-              <a:rPr sz="2200" b="1" lang="zh-CN">
+              <a:rPr lang="zh-CN" sz="2200" b="1">
                 <a:solidFill>
                   <a:srgbClr val="FFFFFF"/>
                 </a:solidFill>
-                <a:latin typeface="微软雅黑"/>
-                <a:ea typeface="微软雅黑"/>
+                <a:latin typeface="微软雅黑" panose="020B0503020204020204" charset="-122"/>
+                <a:ea typeface="微软雅黑" panose="020B0503020204020204" charset="-122"/>
               </a:rPr>
               <a:t>代表案例</a:t>
             </a:r>
@@ -8701,8 +8792,8 @@
               <a:solidFill>
                 <a:schemeClr val="bg1"/>
               </a:solidFill>
-              <a:latin typeface="微软雅黑" panose="020B0503020204020204" pitchFamily="34" charset="-122"/>
-              <a:ea typeface="微软雅黑" panose="020B0503020204020204" pitchFamily="34" charset="-122"/>
+              <a:latin typeface="微软雅黑" panose="020B0503020204020204" charset="-122"/>
+              <a:ea typeface="微软雅黑" panose="020B0503020204020204" charset="-122"/>
               <a:cs typeface="Calibri" panose="020F0502020204030204" pitchFamily="34" charset="0"/>
             </a:endParaRPr>
           </a:p>
@@ -8753,7 +8844,7 @@
           </a:fontRef>
         </p:style>
         <p:txBody>
-          <a:bodyPr lIns="73152" rIns="73152" rtlCol="0" anchor="ctr" tIns="27432" bIns="27432" wrap="square"/>
+          <a:bodyPr wrap="square" lIns="73152" tIns="27432" rIns="73152" bIns="27432" rtlCol="0" anchor="ctr"/>
           <a:lstStyle/>
           <a:p>
             <a:pPr algn="ctr">
@@ -8768,12 +8859,12 @@
               </a:spcAft>
             </a:pPr>
             <a:r>
-              <a:rPr sz="2200" b="0" lang="zh-CN">
+              <a:rPr lang="zh-CN" sz="2200" b="0">
                 <a:solidFill>
                   <a:srgbClr val="5A5A5A"/>
                 </a:solidFill>
-                <a:latin typeface="微软雅黑"/>
-                <a:ea typeface="微软雅黑"/>
+                <a:latin typeface="微软雅黑" panose="020B0503020204020204" charset="-122"/>
+                <a:ea typeface="微软雅黑" panose="020B0503020204020204" charset="-122"/>
               </a:rPr>
               <a:t>研究展望</a:t>
             </a:r>
@@ -8784,8 +8875,8 @@
                   <a:lumOff val="25000"/>
                 </a:schemeClr>
               </a:solidFill>
-              <a:latin typeface="微软雅黑" panose="020B0503020204020204" pitchFamily="34" charset="-122"/>
-              <a:ea typeface="微软雅黑" panose="020B0503020204020204" pitchFamily="34" charset="-122"/>
+              <a:latin typeface="微软雅黑" panose="020B0503020204020204" charset="-122"/>
+              <a:ea typeface="微软雅黑" panose="020B0503020204020204" charset="-122"/>
               <a:cs typeface="Calibri" panose="020F0502020204030204" pitchFamily="34" charset="0"/>
             </a:endParaRPr>
           </a:p>
@@ -8800,8 +8891,8 @@
           <p:nvPr/>
         </p:nvPicPr>
         <p:blipFill>
-          <a:blip r:embed="rId5"/>
-          <a:srcRect l="6578" r="7126" t="24836" b="24071"/>
+          <a:blip r:embed="rId1"/>
+          <a:srcRect l="6578" t="24836" r="7126" b="24071"/>
           <a:stretch>
             <a:fillRect/>
           </a:stretch>
@@ -8833,7 +8924,7 @@
           <a:noFill/>
         </p:spPr>
         <p:txBody>
-          <a:bodyPr wrap="square" lIns="73152" rIns="73152" tIns="27432" bIns="27432" anchor="ctr">
+          <a:bodyPr wrap="square" lIns="73152" tIns="27432" rIns="73152" bIns="27432" anchor="ctr">
             <a:spAutoFit/>
           </a:bodyPr>
           <a:lstStyle/>
@@ -8850,15 +8941,22 @@
               </a:spcAft>
             </a:pPr>
             <a:r>
-              <a:rPr sz="2600" b="1" lang="zh-CN">
+              <a:rPr lang="zh-CN" sz="2600" b="1">
                 <a:solidFill>
                   <a:srgbClr val="006579"/>
                 </a:solidFill>
-                <a:latin typeface="微软雅黑"/>
-                <a:ea typeface="微软雅黑"/>
+                <a:latin typeface="微软雅黑" panose="020B0503020204020204" charset="-122"/>
+                <a:ea typeface="微软雅黑" panose="020B0503020204020204" charset="-122"/>
               </a:rPr>
               <a:t>设计案例：Agent 在数值反馈中优化波导弯曲</a:t>
             </a:r>
+            <a:endParaRPr lang="zh-CN" sz="2600" b="1">
+              <a:solidFill>
+                <a:srgbClr val="006579"/>
+              </a:solidFill>
+              <a:latin typeface="微软雅黑" panose="020B0503020204020204" charset="-122"/>
+              <a:ea typeface="微软雅黑" panose="020B0503020204020204" charset="-122"/>
+            </a:endParaRPr>
           </a:p>
         </p:txBody>
       </p:sp>
@@ -8879,7 +8977,7 @@
           <a:noFill/>
         </p:spPr>
         <p:txBody>
-          <a:bodyPr wrap="square" lIns="73152" rIns="73152" tIns="27432" bIns="27432" anchor="ctr">
+          <a:bodyPr wrap="square" lIns="73152" tIns="27432" rIns="73152" bIns="27432" anchor="ctr">
             <a:spAutoFit/>
           </a:bodyPr>
           <a:lstStyle/>
@@ -8896,15 +8994,22 @@
               </a:spcAft>
             </a:pPr>
             <a:r>
-              <a:rPr sz="1600" b="0" lang="zh-CN">
+              <a:rPr lang="zh-CN" sz="1600" b="0">
                 <a:solidFill>
                   <a:srgbClr val="5A5A5A"/>
                 </a:solidFill>
-                <a:latin typeface="微软雅黑"/>
-                <a:ea typeface="微软雅黑"/>
+                <a:latin typeface="微软雅黑" panose="020B0503020204020204" charset="-122"/>
+                <a:ea typeface="微软雅黑" panose="020B0503020204020204" charset="-122"/>
               </a:rPr>
               <a:t>Kharel 等（2026）：显式规则与电磁求解器驱动的自主设计迭代</a:t>
             </a:r>
+            <a:endParaRPr lang="zh-CN" sz="1600" b="0">
+              <a:solidFill>
+                <a:srgbClr val="5A5A5A"/>
+              </a:solidFill>
+              <a:latin typeface="微软雅黑" panose="020B0503020204020204" charset="-122"/>
+              <a:ea typeface="微软雅黑" panose="020B0503020204020204" charset="-122"/>
+            </a:endParaRPr>
           </a:p>
         </p:txBody>
       </p:sp>
@@ -8960,8 +9065,8 @@
           <a:p>
             <a:pPr algn="ctr"/>
             <a:endParaRPr lang="zh-CN" altLang="en-US" dirty="0">
-              <a:latin typeface="微软雅黑" panose="020B0503020204020204" pitchFamily="34" charset="-122"/>
-              <a:ea typeface="微软雅黑" panose="020B0503020204020204" pitchFamily="34" charset="-122"/>
+              <a:latin typeface="微软雅黑" panose="020B0503020204020204" charset="-122"/>
+              <a:ea typeface="微软雅黑" panose="020B0503020204020204" charset="-122"/>
             </a:endParaRPr>
           </a:p>
         </p:txBody>
@@ -8983,7 +9088,7 @@
           <a:noFill/>
         </p:spPr>
         <p:txBody>
-          <a:bodyPr wrap="square" lIns="73152" rIns="73152" tIns="27432" bIns="27432" anchor="ctr">
+          <a:bodyPr wrap="square" lIns="73152" tIns="27432" rIns="73152" bIns="27432" anchor="ctr">
             <a:spAutoFit/>
           </a:bodyPr>
           <a:lstStyle/>
@@ -9000,15 +9105,22 @@
               </a:spcAft>
             </a:pPr>
             <a:r>
-              <a:rPr sz="1800" b="1" lang="zh-CN">
+              <a:rPr lang="zh-CN" sz="1800" b="1">
                 <a:solidFill>
                   <a:srgbClr val="006579"/>
                 </a:solidFill>
-                <a:latin typeface="微软雅黑"/>
-                <a:ea typeface="微软雅黑"/>
+                <a:latin typeface="微软雅黑" panose="020B0503020204020204" charset="-122"/>
+                <a:ea typeface="微软雅黑" panose="020B0503020204020204" charset="-122"/>
               </a:rPr>
               <a:t>50 次仿真预算中的设计探索</a:t>
             </a:r>
+            <a:endParaRPr lang="zh-CN" sz="1800" b="1">
+              <a:solidFill>
+                <a:srgbClr val="006579"/>
+              </a:solidFill>
+              <a:latin typeface="微软雅黑" panose="020B0503020204020204" charset="-122"/>
+              <a:ea typeface="微软雅黑" panose="020B0503020204020204" charset="-122"/>
+            </a:endParaRPr>
           </a:p>
         </p:txBody>
       </p:sp>
@@ -9021,7 +9133,7 @@
           <p:nvPr/>
         </p:nvPicPr>
         <p:blipFill>
-          <a:blip r:embed="rId6"/>
+          <a:blip r:embed="rId2"/>
           <a:stretch>
             <a:fillRect/>
           </a:stretch>
@@ -9109,7 +9221,7 @@
           </a:fontRef>
         </p:style>
         <p:txBody>
-          <a:bodyPr wrap="square" rtlCol="0" lIns="73152" rIns="73152" tIns="27432" bIns="27432" anchor="ctr">
+          <a:bodyPr wrap="square" lIns="73152" tIns="27432" rIns="73152" bIns="27432" rtlCol="0" anchor="ctr">
             <a:noAutofit/>
           </a:bodyPr>
           <a:lstStyle/>
@@ -9126,18 +9238,18 @@
               </a:spcAft>
             </a:pPr>
             <a:r>
-              <a:rPr sz="2200" b="1" lang="zh-CN">
+              <a:rPr lang="zh-CN" sz="2200" b="1">
                 <a:solidFill>
                   <a:srgbClr val="383838"/>
                 </a:solidFill>
-                <a:latin typeface="微软雅黑"/>
-                <a:ea typeface="微软雅黑"/>
+                <a:latin typeface="微软雅黑" panose="020B0503020204020204" charset="-122"/>
+                <a:ea typeface="微软雅黑" panose="020B0503020204020204" charset="-122"/>
               </a:rPr>
               <a:t>作者仿真结果</a:t>
             </a:r>
             <a:endParaRPr lang="zh-CN" altLang="en-US" sz="2400" b="1" dirty="0">
-              <a:latin typeface="微软雅黑" panose="020B0503020204020204" pitchFamily="34" charset="-122"/>
-              <a:ea typeface="微软雅黑" panose="020B0503020204020204" pitchFamily="34" charset="-122"/>
+              <a:latin typeface="微软雅黑" panose="020B0503020204020204" charset="-122"/>
+              <a:ea typeface="微软雅黑" panose="020B0503020204020204" charset="-122"/>
               <a:cs typeface="Calibri" panose="020F0502020204030204" pitchFamily="34" charset="0"/>
             </a:endParaRPr>
           </a:p>
@@ -9160,7 +9272,7 @@
           <a:noFill/>
         </p:spPr>
         <p:txBody>
-          <a:bodyPr wrap="square" lIns="73152" rIns="73152" tIns="27432" bIns="27432" anchor="ctr">
+          <a:bodyPr wrap="square" lIns="73152" tIns="27432" rIns="73152" bIns="27432" anchor="ctr">
             <a:spAutoFit/>
           </a:bodyPr>
           <a:lstStyle/>
@@ -9177,15 +9289,22 @@
               </a:spcAft>
             </a:pPr>
             <a:r>
-              <a:rPr sz="2700" b="1" lang="zh-CN">
+              <a:rPr lang="zh-CN" sz="2700" b="1">
                 <a:solidFill>
                   <a:srgbClr val="006579"/>
                 </a:solidFill>
-                <a:latin typeface="微软雅黑"/>
-                <a:ea typeface="微软雅黑"/>
+                <a:latin typeface="微软雅黑" panose="020B0503020204020204" charset="-122"/>
+                <a:ea typeface="微软雅黑" panose="020B0503020204020204" charset="-122"/>
               </a:rPr>
               <a:t>0.460 → 0.109 dB</a:t>
             </a:r>
+            <a:endParaRPr lang="zh-CN" sz="2700" b="1">
+              <a:solidFill>
+                <a:srgbClr val="006579"/>
+              </a:solidFill>
+              <a:latin typeface="微软雅黑" panose="020B0503020204020204" charset="-122"/>
+              <a:ea typeface="微软雅黑" panose="020B0503020204020204" charset="-122"/>
+            </a:endParaRPr>
           </a:p>
         </p:txBody>
       </p:sp>
@@ -9206,7 +9325,7 @@
           <a:noFill/>
         </p:spPr>
         <p:txBody>
-          <a:bodyPr wrap="square" lIns="73152" rIns="73152" tIns="27432" bIns="27432" anchor="ctr">
+          <a:bodyPr wrap="square" lIns="73152" tIns="27432" rIns="73152" bIns="27432" anchor="ctr">
             <a:spAutoFit/>
           </a:bodyPr>
           <a:lstStyle/>
@@ -9223,15 +9342,22 @@
               </a:spcAft>
             </a:pPr>
             <a:r>
-              <a:rPr sz="1500" b="0" lang="zh-CN">
+              <a:rPr lang="zh-CN" sz="1500" b="0">
                 <a:solidFill>
                   <a:srgbClr val="5A5A5A"/>
                 </a:solidFill>
-                <a:latin typeface="微软雅黑"/>
-                <a:ea typeface="微软雅黑"/>
+                <a:latin typeface="微软雅黑" panose="020B0503020204020204" charset="-122"/>
+                <a:ea typeface="微软雅黑" panose="020B0503020204020204" charset="-122"/>
               </a:rPr>
               <a:t>圆弧基线 → 最优弯曲损耗</a:t>
             </a:r>
+            <a:endParaRPr lang="zh-CN" sz="1500" b="0">
+              <a:solidFill>
+                <a:srgbClr val="5A5A5A"/>
+              </a:solidFill>
+              <a:latin typeface="微软雅黑" panose="020B0503020204020204" charset="-122"/>
+              <a:ea typeface="微软雅黑" panose="020B0503020204020204" charset="-122"/>
+            </a:endParaRPr>
           </a:p>
         </p:txBody>
       </p:sp>
@@ -9252,7 +9378,7 @@
           <a:noFill/>
         </p:spPr>
         <p:txBody>
-          <a:bodyPr wrap="square" lIns="73152" rIns="73152" tIns="27432" bIns="27432" anchor="ctr">
+          <a:bodyPr wrap="square" lIns="73152" tIns="27432" rIns="73152" bIns="27432" anchor="ctr">
             <a:spAutoFit/>
           </a:bodyPr>
           <a:lstStyle/>
@@ -9269,15 +9395,22 @@
               </a:spcAft>
             </a:pPr>
             <a:r>
-              <a:rPr sz="1800" b="1" lang="zh-CN">
+              <a:rPr lang="zh-CN" sz="1800" b="1">
                 <a:solidFill>
                   <a:srgbClr val="006579"/>
                 </a:solidFill>
-                <a:latin typeface="微软雅黑"/>
-                <a:ea typeface="微软雅黑"/>
+                <a:latin typeface="微软雅黑" panose="020B0503020204020204" charset="-122"/>
+                <a:ea typeface="微软雅黑" panose="020B0503020204020204" charset="-122"/>
               </a:rPr>
               <a:t>仿真条件</a:t>
             </a:r>
+            <a:endParaRPr lang="zh-CN" sz="1800" b="1">
+              <a:solidFill>
+                <a:srgbClr val="006579"/>
+              </a:solidFill>
+              <a:latin typeface="微软雅黑" panose="020B0503020204020204" charset="-122"/>
+              <a:ea typeface="微软雅黑" panose="020B0503020204020204" charset="-122"/>
+            </a:endParaRPr>
           </a:p>
         </p:txBody>
       </p:sp>
@@ -9298,7 +9431,7 @@
           <a:noFill/>
         </p:spPr>
         <p:txBody>
-          <a:bodyPr wrap="square" lIns="73152" rIns="73152" tIns="27432" bIns="27432" anchor="ctr">
+          <a:bodyPr wrap="square" lIns="73152" tIns="27432" rIns="73152" bIns="27432" anchor="ctr">
             <a:spAutoFit/>
           </a:bodyPr>
           <a:lstStyle/>
@@ -9315,15 +9448,22 @@
               </a:spcAft>
             </a:pPr>
             <a:r>
-              <a:rPr sz="1600" b="0" lang="zh-CN">
+              <a:rPr lang="zh-CN" sz="1600" b="0">
                 <a:solidFill>
                   <a:srgbClr val="5A5A5A"/>
                 </a:solidFill>
-                <a:latin typeface="微软雅黑"/>
-                <a:ea typeface="微软雅黑"/>
+                <a:latin typeface="微软雅黑" panose="020B0503020204020204" charset="-122"/>
+                <a:ea typeface="微软雅黑" panose="020B0503020204020204" charset="-122"/>
               </a:rPr>
               <a:t>400 nm SiN；1550 nm</a:t>
             </a:r>
+            <a:endParaRPr lang="zh-CN" sz="1600" b="0">
+              <a:solidFill>
+                <a:srgbClr val="5A5A5A"/>
+              </a:solidFill>
+              <a:latin typeface="微软雅黑" panose="020B0503020204020204" charset="-122"/>
+              <a:ea typeface="微软雅黑" panose="020B0503020204020204" charset="-122"/>
+            </a:endParaRPr>
           </a:p>
           <a:p>
             <a:pPr algn="l">
@@ -9338,15 +9478,22 @@
               </a:spcAft>
             </a:pPr>
             <a:r>
-              <a:rPr sz="1600" b="0" lang="zh-CN">
+              <a:rPr lang="zh-CN" sz="1600" b="0">
                 <a:solidFill>
                   <a:srgbClr val="5A5A5A"/>
                 </a:solidFill>
-                <a:latin typeface="微软雅黑"/>
-                <a:ea typeface="微软雅黑"/>
+                <a:latin typeface="微软雅黑" panose="020B0503020204020204" charset="-122"/>
+                <a:ea typeface="微软雅黑" panose="020B0503020204020204" charset="-122"/>
               </a:rPr>
               <a:t>12 μm 弯曲半径</a:t>
             </a:r>
+            <a:endParaRPr lang="zh-CN" sz="1600" b="0">
+              <a:solidFill>
+                <a:srgbClr val="5A5A5A"/>
+              </a:solidFill>
+              <a:latin typeface="微软雅黑" panose="020B0503020204020204" charset="-122"/>
+              <a:ea typeface="微软雅黑" panose="020B0503020204020204" charset="-122"/>
+            </a:endParaRPr>
           </a:p>
           <a:p>
             <a:pPr algn="l">
@@ -9361,15 +9508,22 @@
               </a:spcAft>
             </a:pPr>
             <a:r>
-              <a:rPr sz="1600" b="0" lang="zh-CN">
+              <a:rPr lang="zh-CN" sz="1600" b="0">
                 <a:solidFill>
                   <a:srgbClr val="5A5A5A"/>
                 </a:solidFill>
-                <a:latin typeface="微软雅黑"/>
-                <a:ea typeface="微软雅黑"/>
+                <a:latin typeface="微软雅黑" panose="020B0503020204020204" charset="-122"/>
+                <a:ea typeface="微软雅黑" panose="020B0503020204020204" charset="-122"/>
               </a:rPr>
               <a:t>150 nm 最小特征</a:t>
             </a:r>
+            <a:endParaRPr lang="zh-CN" sz="1600" b="0">
+              <a:solidFill>
+                <a:srgbClr val="5A5A5A"/>
+              </a:solidFill>
+              <a:latin typeface="微软雅黑" panose="020B0503020204020204" charset="-122"/>
+              <a:ea typeface="微软雅黑" panose="020B0503020204020204" charset="-122"/>
+            </a:endParaRPr>
           </a:p>
         </p:txBody>
       </p:sp>
@@ -9390,7 +9544,7 @@
           <a:noFill/>
         </p:spPr>
         <p:txBody>
-          <a:bodyPr wrap="square" lIns="73152" rIns="73152" tIns="27432" bIns="27432" anchor="ctr">
+          <a:bodyPr wrap="square" lIns="73152" tIns="27432" rIns="73152" bIns="27432" anchor="ctr">
             <a:spAutoFit/>
           </a:bodyPr>
           <a:lstStyle/>
@@ -9407,15 +9561,22 @@
               </a:spcAft>
             </a:pPr>
             <a:r>
-              <a:rPr sz="1400" b="0" lang="zh-CN">
+              <a:rPr lang="zh-CN" sz="1400" b="0">
                 <a:solidFill>
                   <a:srgbClr val="5A5A5A"/>
                 </a:solidFill>
-                <a:latin typeface="微软雅黑"/>
-                <a:ea typeface="微软雅黑"/>
+                <a:latin typeface="微软雅黑" panose="020B0503020204020204" charset="-122"/>
+                <a:ea typeface="微软雅黑" panose="020B0503020204020204" charset="-122"/>
               </a:rPr>
               <a:t>绿色：保留与最优值；红叉：丢弃候选</a:t>
             </a:r>
+            <a:endParaRPr lang="zh-CN" sz="1400" b="0">
+              <a:solidFill>
+                <a:srgbClr val="5A5A5A"/>
+              </a:solidFill>
+              <a:latin typeface="微软雅黑" panose="020B0503020204020204" charset="-122"/>
+              <a:ea typeface="微软雅黑" panose="020B0503020204020204" charset="-122"/>
+            </a:endParaRPr>
           </a:p>
           <a:p>
             <a:pPr algn="l">
@@ -9430,15 +9591,22 @@
               </a:spcAft>
             </a:pPr>
             <a:r>
-              <a:rPr sz="1400" b="0" lang="zh-CN">
+              <a:rPr lang="zh-CN" sz="1400" b="0">
                 <a:solidFill>
                   <a:srgbClr val="5A5A5A"/>
                 </a:solidFill>
-                <a:latin typeface="微软雅黑"/>
-                <a:ea typeface="微软雅黑"/>
+                <a:latin typeface="微软雅黑" panose="020B0503020204020204" charset="-122"/>
+                <a:ea typeface="微软雅黑" panose="020B0503020204020204" charset="-122"/>
               </a:rPr>
               <a:t>迭代依据：规则检查与数值反馈</a:t>
             </a:r>
+            <a:endParaRPr lang="zh-CN" sz="1400" b="0">
+              <a:solidFill>
+                <a:srgbClr val="5A5A5A"/>
+              </a:solidFill>
+              <a:latin typeface="微软雅黑" panose="020B0503020204020204" charset="-122"/>
+              <a:ea typeface="微软雅黑" panose="020B0503020204020204" charset="-122"/>
+            </a:endParaRPr>
           </a:p>
           <a:p>
             <a:pPr algn="l">
@@ -9453,15 +9621,22 @@
               </a:spcAft>
             </a:pPr>
             <a:r>
-              <a:rPr sz="1400" b="0" lang="zh-CN">
+              <a:rPr lang="zh-CN" sz="1400" b="0">
                 <a:solidFill>
                   <a:srgbClr val="5A5A5A"/>
                 </a:solidFill>
-                <a:latin typeface="微软雅黑"/>
-                <a:ea typeface="微软雅黑"/>
+                <a:latin typeface="微软雅黑" panose="020B0503020204020204" charset="-122"/>
+                <a:ea typeface="微软雅黑" panose="020B0503020204020204" charset="-122"/>
               </a:rPr>
               <a:t>论文仿真案例，尚非流片实测</a:t>
             </a:r>
+            <a:endParaRPr lang="zh-CN" sz="1400" b="0">
+              <a:solidFill>
+                <a:srgbClr val="5A5A5A"/>
+              </a:solidFill>
+              <a:latin typeface="微软雅黑" panose="020B0503020204020204" charset="-122"/>
+              <a:ea typeface="微软雅黑" panose="020B0503020204020204" charset="-122"/>
+            </a:endParaRPr>
           </a:p>
         </p:txBody>
       </p:sp>
@@ -9482,7 +9657,7 @@
           <a:noFill/>
         </p:spPr>
         <p:txBody>
-          <a:bodyPr wrap="square" lIns="73152" rIns="73152" tIns="27432" bIns="27432" anchor="ctr">
+          <a:bodyPr wrap="square" lIns="73152" tIns="27432" rIns="73152" bIns="27432" anchor="ctr">
             <a:spAutoFit/>
           </a:bodyPr>
           <a:lstStyle/>
@@ -9499,21 +9674,28 @@
               </a:spcAft>
             </a:pPr>
             <a:r>
-              <a:rPr sz="900" b="0" lang="zh-CN">
+              <a:rPr lang="zh-CN" sz="900" b="0">
                 <a:solidFill>
                   <a:srgbClr val="5A5A5A"/>
                 </a:solidFill>
-                <a:latin typeface="微软雅黑"/>
-                <a:ea typeface="微软雅黑"/>
+                <a:latin typeface="微软雅黑" panose="020B0503020204020204" charset="-122"/>
+                <a:ea typeface="微软雅黑" panose="020B0503020204020204" charset="-122"/>
               </a:rPr>
               <a:t>Kharel et al., 2026, Autonomous agentic design for photonics, Fig. 2(a), §S2.1. DOI: 10.48550/arXiv.2606.00915</a:t>
             </a:r>
+            <a:endParaRPr lang="zh-CN" sz="900" b="0">
+              <a:solidFill>
+                <a:srgbClr val="5A5A5A"/>
+              </a:solidFill>
+              <a:latin typeface="微软雅黑" panose="020B0503020204020204" charset="-122"/>
+              <a:ea typeface="微软雅黑" panose="020B0503020204020204" charset="-122"/>
+            </a:endParaRPr>
           </a:p>
         </p:txBody>
       </p:sp>
     </p:spTree>
     <p:custDataLst>
-      <p:tags r:id="rId2"/>
+      <p:tags r:id="rId3"/>
     </p:custDataLst>
   </p:cSld>
   <p:clrMapOvr>
@@ -9522,7 +9704,7 @@
 </p:sld>
 </file>
 
-<file path=ppt/tags/tag12.xml><?xml version="1.0" encoding="utf-8"?>
+<file path=ppt/tags/tag1.xml><?xml version="1.0" encoding="utf-8"?>
 <p:tagLst xmlns:p="http://schemas.openxmlformats.org/presentationml/2006/main">
   <p:tag name="TIMING" val="|36.1"/>
 </p:tagLst>

</xml_diff>